<commit_message>
Refine native Style Kit effects with accessible depth and contrast
Use shared six-effect descriptions for native theme references and HTML previews. Preserve all fixed-master outputs and highlight content. Reviewed exact tree 03595650952d6b67419e6085995fa2d67b414bc4; local candidate 8eafae151df38100a49774fd3a3b360f10708380.
</commit_message>
<xml_diff>
--- a/native-stylekit/common/burgundy.pptx
+++ b/native-stylekit/common/burgundy.pptx
@@ -3931,7 +3931,7 @@
                 <a:latin typeface="+mn-lt"/>
                 <a:ea typeface="+mn-ea"/>
               </a:rPr>
-              <a:t>色彩外框 / Colored Outline</a:t>
+              <a:t>清爽線框 / Clean Outline</a:t>
             </a:r>
             <a:endParaRPr lang="zh-TW"/>
           </a:p>
@@ -3960,7 +3960,7 @@
           <a:fillRef idx="0">
             <a:schemeClr val="tx1"/>
           </a:fillRef>
-          <a:effectRef idx="1">
+          <a:effectRef idx="0">
             <a:schemeClr val="tx1"/>
           </a:effectRef>
           <a:fontRef idx="minor">
@@ -4013,11 +4013,13 @@
           <a:fillRef idx="0">
             <a:schemeClr val="accent1"/>
           </a:fillRef>
-          <a:effectRef idx="1">
+          <a:effectRef idx="0">
             <a:schemeClr val="accent1"/>
           </a:effectRef>
           <a:fontRef idx="minor">
-            <a:schemeClr val="accent1"/>
+            <a:schemeClr val="accent1">
+              <a:shade val="75000"/>
+            </a:schemeClr>
           </a:fontRef>
         </p:style>
         <p:txBody>
@@ -4032,7 +4034,9 @@
             <a:r>
               <a:rPr lang="zh-TW" sz="2000" b="1">
                 <a:solidFill>
-                  <a:schemeClr val="accent1"/>
+                  <a:schemeClr val="accent1">
+                    <a:shade val="75000"/>
+                  </a:schemeClr>
                 </a:solidFill>
                 <a:latin typeface="+mn-lt"/>
                 <a:ea typeface="+mn-ea"/>
@@ -4066,11 +4070,13 @@
           <a:fillRef idx="0">
             <a:schemeClr val="accent2"/>
           </a:fillRef>
-          <a:effectRef idx="1">
+          <a:effectRef idx="0">
             <a:schemeClr val="accent2"/>
           </a:effectRef>
           <a:fontRef idx="minor">
-            <a:schemeClr val="accent2"/>
+            <a:schemeClr val="accent2">
+              <a:shade val="30000"/>
+            </a:schemeClr>
           </a:fontRef>
         </p:style>
         <p:txBody>
@@ -4085,7 +4091,9 @@
             <a:r>
               <a:rPr lang="zh-TW" sz="2000" b="1">
                 <a:solidFill>
-                  <a:schemeClr val="accent2"/>
+                  <a:schemeClr val="accent2">
+                    <a:shade val="30000"/>
+                  </a:schemeClr>
                 </a:solidFill>
                 <a:latin typeface="+mn-lt"/>
                 <a:ea typeface="+mn-ea"/>
@@ -4119,11 +4127,13 @@
           <a:fillRef idx="0">
             <a:schemeClr val="accent3"/>
           </a:fillRef>
-          <a:effectRef idx="1">
+          <a:effectRef idx="0">
             <a:schemeClr val="accent3"/>
           </a:effectRef>
           <a:fontRef idx="minor">
-            <a:schemeClr val="accent3"/>
+            <a:schemeClr val="accent3">
+              <a:shade val="80000"/>
+            </a:schemeClr>
           </a:fontRef>
         </p:style>
         <p:txBody>
@@ -4138,7 +4148,9 @@
             <a:r>
               <a:rPr lang="zh-TW" sz="2000" b="1">
                 <a:solidFill>
-                  <a:schemeClr val="accent3"/>
+                  <a:schemeClr val="accent3">
+                    <a:shade val="80000"/>
+                  </a:schemeClr>
                 </a:solidFill>
                 <a:latin typeface="+mn-lt"/>
                 <a:ea typeface="+mn-ea"/>
@@ -4172,11 +4184,13 @@
           <a:fillRef idx="0">
             <a:schemeClr val="accent4"/>
           </a:fillRef>
-          <a:effectRef idx="1">
+          <a:effectRef idx="0">
             <a:schemeClr val="accent4"/>
           </a:effectRef>
           <a:fontRef idx="minor">
-            <a:schemeClr val="accent4"/>
+            <a:schemeClr val="accent4">
+              <a:shade val="70000"/>
+            </a:schemeClr>
           </a:fontRef>
         </p:style>
         <p:txBody>
@@ -4191,7 +4205,9 @@
             <a:r>
               <a:rPr lang="zh-TW" sz="2000" b="1">
                 <a:solidFill>
-                  <a:schemeClr val="accent4"/>
+                  <a:schemeClr val="accent4">
+                    <a:shade val="70000"/>
+                  </a:schemeClr>
                 </a:solidFill>
                 <a:latin typeface="+mn-lt"/>
                 <a:ea typeface="+mn-ea"/>
@@ -4225,11 +4241,13 @@
           <a:fillRef idx="0">
             <a:schemeClr val="accent5"/>
           </a:fillRef>
-          <a:effectRef idx="1">
+          <a:effectRef idx="0">
             <a:schemeClr val="accent5"/>
           </a:effectRef>
           <a:fontRef idx="minor">
-            <a:schemeClr val="accent5"/>
+            <a:schemeClr val="accent5">
+              <a:shade val="70000"/>
+            </a:schemeClr>
           </a:fontRef>
         </p:style>
         <p:txBody>
@@ -4244,7 +4262,9 @@
             <a:r>
               <a:rPr lang="zh-TW" sz="2000" b="1">
                 <a:solidFill>
-                  <a:schemeClr val="accent5"/>
+                  <a:schemeClr val="accent5">
+                    <a:shade val="70000"/>
+                  </a:schemeClr>
                 </a:solidFill>
                 <a:latin typeface="+mn-lt"/>
                 <a:ea typeface="+mn-ea"/>
@@ -4278,11 +4298,13 @@
           <a:fillRef idx="0">
             <a:schemeClr val="accent6"/>
           </a:fillRef>
-          <a:effectRef idx="1">
+          <a:effectRef idx="0">
             <a:schemeClr val="accent6"/>
           </a:effectRef>
           <a:fontRef idx="minor">
-            <a:schemeClr val="accent6"/>
+            <a:schemeClr val="accent6">
+              <a:shade val="80000"/>
+            </a:schemeClr>
           </a:fontRef>
         </p:style>
         <p:txBody>
@@ -4297,7 +4319,9 @@
             <a:r>
               <a:rPr lang="zh-TW" sz="2000" b="1">
                 <a:solidFill>
-                  <a:schemeClr val="accent6"/>
+                  <a:schemeClr val="accent6">
+                    <a:shade val="80000"/>
+                  </a:schemeClr>
                 </a:solidFill>
                 <a:latin typeface="+mn-lt"/>
                 <a:ea typeface="+mn-ea"/>
@@ -4344,7 +4368,7 @@
                 <a:latin typeface="+mn-lt"/>
                 <a:ea typeface="+mn-ea"/>
               </a:rPr>
-              <a:t>色彩填滿 / Colored Fill</a:t>
+              <a:t>主色實心 / Solid Color</a:t>
             </a:r>
             <a:endParaRPr lang="zh-TW"/>
           </a:p>
@@ -4368,13 +4392,13 @@
         <p:style>
           <a:lnRef idx="1">
             <a:schemeClr val="tx1">
-              <a:shade val="50000"/>
+              <a:shade val="80000"/>
             </a:schemeClr>
           </a:lnRef>
           <a:fillRef idx="1">
             <a:schemeClr val="tx1"/>
           </a:fillRef>
-          <a:effectRef idx="1">
+          <a:effectRef idx="0">
             <a:schemeClr val="tx1"/>
           </a:effectRef>
           <a:fontRef idx="minor">
@@ -4422,17 +4446,17 @@
         <p:style>
           <a:lnRef idx="1">
             <a:schemeClr val="accent1">
-              <a:shade val="50000"/>
+              <a:shade val="80000"/>
             </a:schemeClr>
           </a:lnRef>
           <a:fillRef idx="1">
             <a:schemeClr val="accent1"/>
           </a:fillRef>
-          <a:effectRef idx="1">
+          <a:effectRef idx="0">
             <a:schemeClr val="accent1"/>
           </a:effectRef>
           <a:fontRef idx="minor">
-            <a:schemeClr val="lt1"/>
+            <a:schemeClr val="tx1"/>
           </a:fontRef>
         </p:style>
         <p:txBody>
@@ -4447,7 +4471,7 @@
             <a:r>
               <a:rPr lang="zh-TW" sz="2000" b="1">
                 <a:solidFill>
-                  <a:schemeClr val="lt1"/>
+                  <a:schemeClr val="tx1"/>
                 </a:solidFill>
                 <a:latin typeface="+mn-lt"/>
                 <a:ea typeface="+mn-ea"/>
@@ -4476,13 +4500,13 @@
         <p:style>
           <a:lnRef idx="1">
             <a:schemeClr val="accent2">
-              <a:shade val="50000"/>
+              <a:shade val="80000"/>
             </a:schemeClr>
           </a:lnRef>
           <a:fillRef idx="1">
             <a:schemeClr val="accent2"/>
           </a:fillRef>
-          <a:effectRef idx="1">
+          <a:effectRef idx="0">
             <a:schemeClr val="accent2"/>
           </a:effectRef>
           <a:fontRef idx="minor">
@@ -4530,17 +4554,17 @@
         <p:style>
           <a:lnRef idx="1">
             <a:schemeClr val="accent3">
-              <a:shade val="50000"/>
+              <a:shade val="80000"/>
             </a:schemeClr>
           </a:lnRef>
           <a:fillRef idx="1">
             <a:schemeClr val="accent3"/>
           </a:fillRef>
-          <a:effectRef idx="1">
+          <a:effectRef idx="0">
             <a:schemeClr val="accent3"/>
           </a:effectRef>
           <a:fontRef idx="minor">
-            <a:schemeClr val="lt1"/>
+            <a:schemeClr val="tx1"/>
           </a:fontRef>
         </p:style>
         <p:txBody>
@@ -4555,7 +4579,7 @@
             <a:r>
               <a:rPr lang="zh-TW" sz="2000" b="1">
                 <a:solidFill>
-                  <a:schemeClr val="lt1"/>
+                  <a:schemeClr val="tx1"/>
                 </a:solidFill>
                 <a:latin typeface="+mn-lt"/>
                 <a:ea typeface="+mn-ea"/>
@@ -4584,17 +4608,17 @@
         <p:style>
           <a:lnRef idx="1">
             <a:schemeClr val="accent4">
-              <a:shade val="50000"/>
+              <a:shade val="80000"/>
             </a:schemeClr>
           </a:lnRef>
           <a:fillRef idx="1">
             <a:schemeClr val="accent4"/>
           </a:fillRef>
-          <a:effectRef idx="1">
+          <a:effectRef idx="0">
             <a:schemeClr val="accent4"/>
           </a:effectRef>
           <a:fontRef idx="minor">
-            <a:schemeClr val="lt1"/>
+            <a:schemeClr val="tx1"/>
           </a:fontRef>
         </p:style>
         <p:txBody>
@@ -4609,7 +4633,7 @@
             <a:r>
               <a:rPr lang="zh-TW" sz="2000" b="1">
                 <a:solidFill>
-                  <a:schemeClr val="lt1"/>
+                  <a:schemeClr val="tx1"/>
                 </a:solidFill>
                 <a:latin typeface="+mn-lt"/>
                 <a:ea typeface="+mn-ea"/>
@@ -4638,17 +4662,17 @@
         <p:style>
           <a:lnRef idx="1">
             <a:schemeClr val="accent5">
-              <a:shade val="50000"/>
+              <a:shade val="80000"/>
             </a:schemeClr>
           </a:lnRef>
           <a:fillRef idx="1">
             <a:schemeClr val="accent5"/>
           </a:fillRef>
-          <a:effectRef idx="1">
+          <a:effectRef idx="0">
             <a:schemeClr val="accent5"/>
           </a:effectRef>
           <a:fontRef idx="minor">
-            <a:schemeClr val="lt1"/>
+            <a:schemeClr val="tx1"/>
           </a:fontRef>
         </p:style>
         <p:txBody>
@@ -4663,7 +4687,7 @@
             <a:r>
               <a:rPr lang="zh-TW" sz="2000" b="1">
                 <a:solidFill>
-                  <a:schemeClr val="lt1"/>
+                  <a:schemeClr val="tx1"/>
                 </a:solidFill>
                 <a:latin typeface="+mn-lt"/>
                 <a:ea typeface="+mn-ea"/>
@@ -4692,17 +4716,17 @@
         <p:style>
           <a:lnRef idx="1">
             <a:schemeClr val="accent6">
-              <a:shade val="50000"/>
+              <a:shade val="80000"/>
             </a:schemeClr>
           </a:lnRef>
           <a:fillRef idx="1">
             <a:schemeClr val="accent6"/>
           </a:fillRef>
-          <a:effectRef idx="1">
+          <a:effectRef idx="0">
             <a:schemeClr val="accent6"/>
           </a:effectRef>
           <a:fontRef idx="minor">
-            <a:schemeClr val="lt1"/>
+            <a:schemeClr val="tx1"/>
           </a:fontRef>
         </p:style>
         <p:txBody>
@@ -4717,7 +4741,7 @@
             <a:r>
               <a:rPr lang="zh-TW" sz="2000" b="1">
                 <a:solidFill>
-                  <a:schemeClr val="lt1"/>
+                  <a:schemeClr val="tx1"/>
                 </a:solidFill>
                 <a:latin typeface="+mn-lt"/>
                 <a:ea typeface="+mn-ea"/>
@@ -4764,7 +4788,7 @@
                 <a:latin typeface="+mn-lt"/>
                 <a:ea typeface="+mn-ea"/>
               </a:rPr>
-              <a:t>淺色外框＋色彩填滿 / Light 1 Outline</a:t>
+              <a:t>白框浮起 / White Rim Lift</a:t>
             </a:r>
             <a:endParaRPr lang="zh-TW"/>
           </a:p>
@@ -4786,7 +4810,7 @@
           </a:prstGeom>
         </p:spPr>
         <p:style>
-          <a:lnRef idx="1">
+          <a:lnRef idx="2">
             <a:schemeClr val="lt1"/>
           </a:lnRef>
           <a:fillRef idx="1">
@@ -4838,7 +4862,7 @@
           </a:prstGeom>
         </p:spPr>
         <p:style>
-          <a:lnRef idx="1">
+          <a:lnRef idx="2">
             <a:schemeClr val="lt1"/>
           </a:lnRef>
           <a:fillRef idx="1">
@@ -4848,7 +4872,7 @@
             <a:schemeClr val="accent1"/>
           </a:effectRef>
           <a:fontRef idx="minor">
-            <a:schemeClr val="lt1"/>
+            <a:schemeClr val="tx1"/>
           </a:fontRef>
         </p:style>
         <p:txBody>
@@ -4863,7 +4887,7 @@
             <a:r>
               <a:rPr lang="zh-TW" sz="2000" b="1">
                 <a:solidFill>
-                  <a:schemeClr val="lt1"/>
+                  <a:schemeClr val="tx1"/>
                 </a:solidFill>
                 <a:latin typeface="+mn-lt"/>
                 <a:ea typeface="+mn-ea"/>
@@ -4890,7 +4914,7 @@
           </a:prstGeom>
         </p:spPr>
         <p:style>
-          <a:lnRef idx="1">
+          <a:lnRef idx="2">
             <a:schemeClr val="lt1"/>
           </a:lnRef>
           <a:fillRef idx="1">
@@ -4942,7 +4966,7 @@
           </a:prstGeom>
         </p:spPr>
         <p:style>
-          <a:lnRef idx="1">
+          <a:lnRef idx="2">
             <a:schemeClr val="lt1"/>
           </a:lnRef>
           <a:fillRef idx="1">
@@ -4952,7 +4976,7 @@
             <a:schemeClr val="accent3"/>
           </a:effectRef>
           <a:fontRef idx="minor">
-            <a:schemeClr val="lt1"/>
+            <a:schemeClr val="tx1"/>
           </a:fontRef>
         </p:style>
         <p:txBody>
@@ -4967,7 +4991,7 @@
             <a:r>
               <a:rPr lang="zh-TW" sz="2000" b="1">
                 <a:solidFill>
-                  <a:schemeClr val="lt1"/>
+                  <a:schemeClr val="tx1"/>
                 </a:solidFill>
                 <a:latin typeface="+mn-lt"/>
                 <a:ea typeface="+mn-ea"/>
@@ -4994,7 +5018,7 @@
           </a:prstGeom>
         </p:spPr>
         <p:style>
-          <a:lnRef idx="1">
+          <a:lnRef idx="2">
             <a:schemeClr val="lt1"/>
           </a:lnRef>
           <a:fillRef idx="1">
@@ -5004,7 +5028,7 @@
             <a:schemeClr val="accent4"/>
           </a:effectRef>
           <a:fontRef idx="minor">
-            <a:schemeClr val="lt1"/>
+            <a:schemeClr val="tx1"/>
           </a:fontRef>
         </p:style>
         <p:txBody>
@@ -5019,7 +5043,7 @@
             <a:r>
               <a:rPr lang="zh-TW" sz="2000" b="1">
                 <a:solidFill>
-                  <a:schemeClr val="lt1"/>
+                  <a:schemeClr val="tx1"/>
                 </a:solidFill>
                 <a:latin typeface="+mn-lt"/>
                 <a:ea typeface="+mn-ea"/>
@@ -5046,7 +5070,7 @@
           </a:prstGeom>
         </p:spPr>
         <p:style>
-          <a:lnRef idx="1">
+          <a:lnRef idx="2">
             <a:schemeClr val="lt1"/>
           </a:lnRef>
           <a:fillRef idx="1">
@@ -5056,7 +5080,7 @@
             <a:schemeClr val="accent5"/>
           </a:effectRef>
           <a:fontRef idx="minor">
-            <a:schemeClr val="lt1"/>
+            <a:schemeClr val="tx1"/>
           </a:fontRef>
         </p:style>
         <p:txBody>
@@ -5071,7 +5095,7 @@
             <a:r>
               <a:rPr lang="zh-TW" sz="2000" b="1">
                 <a:solidFill>
-                  <a:schemeClr val="lt1"/>
+                  <a:schemeClr val="tx1"/>
                 </a:solidFill>
                 <a:latin typeface="+mn-lt"/>
                 <a:ea typeface="+mn-ea"/>
@@ -5098,7 +5122,7 @@
           </a:prstGeom>
         </p:spPr>
         <p:style>
-          <a:lnRef idx="1">
+          <a:lnRef idx="2">
             <a:schemeClr val="lt1"/>
           </a:lnRef>
           <a:fillRef idx="1">
@@ -5108,7 +5132,7 @@
             <a:schemeClr val="accent6"/>
           </a:effectRef>
           <a:fontRef idx="minor">
-            <a:schemeClr val="lt1"/>
+            <a:schemeClr val="tx1"/>
           </a:fontRef>
         </p:style>
         <p:txBody>
@@ -5123,7 +5147,7 @@
             <a:r>
               <a:rPr lang="zh-TW" sz="2000" b="1">
                 <a:solidFill>
-                  <a:schemeClr val="lt1"/>
+                  <a:schemeClr val="tx1"/>
                 </a:solidFill>
                 <a:latin typeface="+mn-lt"/>
                 <a:ea typeface="+mn-ea"/>
@@ -5170,7 +5194,7 @@
                 <a:latin typeface="+mn-lt"/>
                 <a:ea typeface="+mn-ea"/>
               </a:rPr>
-              <a:t>輕微效果 / Subtle Effect</a:t>
+              <a:t>柔底微浮 / Soft Tint Lift</a:t>
             </a:r>
             <a:endParaRPr lang="zh-TW"/>
           </a:p>
@@ -5192,7 +5216,7 @@
           </a:prstGeom>
         </p:spPr>
         <p:style>
-          <a:lnRef idx="1">
+          <a:lnRef idx="3">
             <a:schemeClr val="tx1"/>
           </a:lnRef>
           <a:fillRef idx="3">
@@ -5244,7 +5268,7 @@
           </a:prstGeom>
         </p:spPr>
         <p:style>
-          <a:lnRef idx="1">
+          <a:lnRef idx="3">
             <a:schemeClr val="accent1"/>
           </a:lnRef>
           <a:fillRef idx="3">
@@ -5254,7 +5278,9 @@
             <a:schemeClr val="accent1"/>
           </a:effectRef>
           <a:fontRef idx="minor">
-            <a:schemeClr val="accent1"/>
+            <a:schemeClr val="accent1">
+              <a:shade val="60000"/>
+            </a:schemeClr>
           </a:fontRef>
         </p:style>
         <p:txBody>
@@ -5269,7 +5295,9 @@
             <a:r>
               <a:rPr lang="zh-TW" sz="2000" b="1">
                 <a:solidFill>
-                  <a:schemeClr val="accent1"/>
+                  <a:schemeClr val="accent1">
+                    <a:shade val="60000"/>
+                  </a:schemeClr>
                 </a:solidFill>
                 <a:latin typeface="+mn-lt"/>
                 <a:ea typeface="+mn-ea"/>
@@ -5296,7 +5324,7 @@
           </a:prstGeom>
         </p:spPr>
         <p:style>
-          <a:lnRef idx="1">
+          <a:lnRef idx="3">
             <a:schemeClr val="accent2"/>
           </a:lnRef>
           <a:fillRef idx="3">
@@ -5306,7 +5334,9 @@
             <a:schemeClr val="accent2"/>
           </a:effectRef>
           <a:fontRef idx="minor">
-            <a:schemeClr val="accent2"/>
+            <a:schemeClr val="accent2">
+              <a:shade val="25000"/>
+            </a:schemeClr>
           </a:fontRef>
         </p:style>
         <p:txBody>
@@ -5321,7 +5351,9 @@
             <a:r>
               <a:rPr lang="zh-TW" sz="2000" b="1">
                 <a:solidFill>
-                  <a:schemeClr val="accent2"/>
+                  <a:schemeClr val="accent2">
+                    <a:shade val="25000"/>
+                  </a:schemeClr>
                 </a:solidFill>
                 <a:latin typeface="+mn-lt"/>
                 <a:ea typeface="+mn-ea"/>
@@ -5348,7 +5380,7 @@
           </a:prstGeom>
         </p:spPr>
         <p:style>
-          <a:lnRef idx="1">
+          <a:lnRef idx="3">
             <a:schemeClr val="accent3"/>
           </a:lnRef>
           <a:fillRef idx="3">
@@ -5358,7 +5390,9 @@
             <a:schemeClr val="accent3"/>
           </a:effectRef>
           <a:fontRef idx="minor">
-            <a:schemeClr val="accent3"/>
+            <a:schemeClr val="accent3">
+              <a:shade val="60000"/>
+            </a:schemeClr>
           </a:fontRef>
         </p:style>
         <p:txBody>
@@ -5373,7 +5407,9 @@
             <a:r>
               <a:rPr lang="zh-TW" sz="2000" b="1">
                 <a:solidFill>
-                  <a:schemeClr val="accent3"/>
+                  <a:schemeClr val="accent3">
+                    <a:shade val="60000"/>
+                  </a:schemeClr>
                 </a:solidFill>
                 <a:latin typeface="+mn-lt"/>
                 <a:ea typeface="+mn-ea"/>
@@ -5400,7 +5436,7 @@
           </a:prstGeom>
         </p:spPr>
         <p:style>
-          <a:lnRef idx="1">
+          <a:lnRef idx="3">
             <a:schemeClr val="accent4"/>
           </a:lnRef>
           <a:fillRef idx="3">
@@ -5410,7 +5446,9 @@
             <a:schemeClr val="accent4"/>
           </a:effectRef>
           <a:fontRef idx="minor">
-            <a:schemeClr val="accent4"/>
+            <a:schemeClr val="accent4">
+              <a:shade val="55000"/>
+            </a:schemeClr>
           </a:fontRef>
         </p:style>
         <p:txBody>
@@ -5425,7 +5463,9 @@
             <a:r>
               <a:rPr lang="zh-TW" sz="2000" b="1">
                 <a:solidFill>
-                  <a:schemeClr val="accent4"/>
+                  <a:schemeClr val="accent4">
+                    <a:shade val="55000"/>
+                  </a:schemeClr>
                 </a:solidFill>
                 <a:latin typeface="+mn-lt"/>
                 <a:ea typeface="+mn-ea"/>
@@ -5452,7 +5492,7 @@
           </a:prstGeom>
         </p:spPr>
         <p:style>
-          <a:lnRef idx="1">
+          <a:lnRef idx="3">
             <a:schemeClr val="accent5"/>
           </a:lnRef>
           <a:fillRef idx="3">
@@ -5462,7 +5502,9 @@
             <a:schemeClr val="accent5"/>
           </a:effectRef>
           <a:fontRef idx="minor">
-            <a:schemeClr val="accent5"/>
+            <a:schemeClr val="accent5">
+              <a:shade val="60000"/>
+            </a:schemeClr>
           </a:fontRef>
         </p:style>
         <p:txBody>
@@ -5477,7 +5519,9 @@
             <a:r>
               <a:rPr lang="zh-TW" sz="2000" b="1">
                 <a:solidFill>
-                  <a:schemeClr val="accent5"/>
+                  <a:schemeClr val="accent5">
+                    <a:shade val="60000"/>
+                  </a:schemeClr>
                 </a:solidFill>
                 <a:latin typeface="+mn-lt"/>
                 <a:ea typeface="+mn-ea"/>
@@ -5504,7 +5548,7 @@
           </a:prstGeom>
         </p:spPr>
         <p:style>
-          <a:lnRef idx="1">
+          <a:lnRef idx="3">
             <a:schemeClr val="accent6"/>
           </a:lnRef>
           <a:fillRef idx="3">
@@ -5514,7 +5558,9 @@
             <a:schemeClr val="accent6"/>
           </a:effectRef>
           <a:fontRef idx="minor">
-            <a:schemeClr val="accent6"/>
+            <a:schemeClr val="accent6">
+              <a:shade val="65000"/>
+            </a:schemeClr>
           </a:fontRef>
         </p:style>
         <p:txBody>
@@ -5529,7 +5575,9 @@
             <a:r>
               <a:rPr lang="zh-TW" sz="2000" b="1">
                 <a:solidFill>
-                  <a:schemeClr val="accent6"/>
+                  <a:schemeClr val="accent6">
+                    <a:shade val="65000"/>
+                  </a:schemeClr>
                 </a:solidFill>
                 <a:latin typeface="+mn-lt"/>
                 <a:ea typeface="+mn-ea"/>
@@ -5576,7 +5624,7 @@
                 <a:latin typeface="+mn-lt"/>
                 <a:ea typeface="+mn-ea"/>
               </a:rPr>
-              <a:t>中度效果 / Moderate Effect</a:t>
+              <a:t>主色微立體 / Subtle Depth</a:t>
             </a:r>
             <a:endParaRPr lang="zh-TW"/>
           </a:p>
@@ -5666,7 +5714,7 @@
             <a:schemeClr val="accent1"/>
           </a:effectRef>
           <a:fontRef idx="minor">
-            <a:schemeClr val="lt1"/>
+            <a:schemeClr val="tx1"/>
           </a:fontRef>
         </p:style>
         <p:txBody>
@@ -5681,7 +5729,7 @@
             <a:r>
               <a:rPr lang="zh-TW" sz="2000" b="1">
                 <a:solidFill>
-                  <a:schemeClr val="lt1"/>
+                  <a:schemeClr val="tx1"/>
                 </a:solidFill>
                 <a:latin typeface="+mn-lt"/>
                 <a:ea typeface="+mn-ea"/>
@@ -5776,7 +5824,7 @@
             <a:schemeClr val="accent3"/>
           </a:effectRef>
           <a:fontRef idx="minor">
-            <a:schemeClr val="lt1"/>
+            <a:schemeClr val="tx1"/>
           </a:fontRef>
         </p:style>
         <p:txBody>
@@ -5791,7 +5839,7 @@
             <a:r>
               <a:rPr lang="zh-TW" sz="2000" b="1">
                 <a:solidFill>
-                  <a:schemeClr val="lt1"/>
+                  <a:schemeClr val="tx1"/>
                 </a:solidFill>
                 <a:latin typeface="+mn-lt"/>
                 <a:ea typeface="+mn-ea"/>
@@ -5831,7 +5879,7 @@
             <a:schemeClr val="accent4"/>
           </a:effectRef>
           <a:fontRef idx="minor">
-            <a:schemeClr val="lt1"/>
+            <a:schemeClr val="tx1"/>
           </a:fontRef>
         </p:style>
         <p:txBody>
@@ -5846,7 +5894,7 @@
             <a:r>
               <a:rPr lang="zh-TW" sz="2000" b="1">
                 <a:solidFill>
-                  <a:schemeClr val="lt1"/>
+                  <a:schemeClr val="tx1"/>
                 </a:solidFill>
                 <a:latin typeface="+mn-lt"/>
                 <a:ea typeface="+mn-ea"/>
@@ -5886,7 +5934,7 @@
             <a:schemeClr val="accent5"/>
           </a:effectRef>
           <a:fontRef idx="minor">
-            <a:schemeClr val="lt1"/>
+            <a:schemeClr val="tx1"/>
           </a:fontRef>
         </p:style>
         <p:txBody>
@@ -5901,7 +5949,7 @@
             <a:r>
               <a:rPr lang="zh-TW" sz="2000" b="1">
                 <a:solidFill>
-                  <a:schemeClr val="lt1"/>
+                  <a:schemeClr val="tx1"/>
                 </a:solidFill>
                 <a:latin typeface="+mn-lt"/>
                 <a:ea typeface="+mn-ea"/>
@@ -5941,7 +5989,7 @@
             <a:schemeClr val="accent6"/>
           </a:effectRef>
           <a:fontRef idx="minor">
-            <a:schemeClr val="lt1"/>
+            <a:schemeClr val="tx1"/>
           </a:fontRef>
         </p:style>
         <p:txBody>
@@ -5956,7 +6004,7 @@
             <a:r>
               <a:rPr lang="zh-TW" sz="2000" b="1">
                 <a:solidFill>
-                  <a:schemeClr val="lt1"/>
+                  <a:schemeClr val="tx1"/>
                 </a:solidFill>
                 <a:latin typeface="+mn-lt"/>
                 <a:ea typeface="+mn-ea"/>
@@ -6003,7 +6051,7 @@
                 <a:latin typeface="+mn-lt"/>
                 <a:ea typeface="+mn-ea"/>
               </a:rPr>
-              <a:t>強烈效果 / Intense Effect</a:t>
+              <a:t>深色浮起 / Deep Color Lift</a:t>
             </a:r>
             <a:endParaRPr lang="zh-TW"/>
           </a:p>
@@ -6032,7 +6080,9 @@
             <a:schemeClr val="tx1"/>
           </a:lnRef>
           <a:fillRef idx="1">
-            <a:schemeClr val="tx1"/>
+            <a:schemeClr val="tx1">
+              <a:shade val="45000"/>
+            </a:schemeClr>
           </a:fillRef>
           <a:effectRef idx="3">
             <a:schemeClr val="tx1"/>
@@ -6087,7 +6137,9 @@
             <a:schemeClr val="accent1"/>
           </a:lnRef>
           <a:fillRef idx="1">
-            <a:schemeClr val="accent1"/>
+            <a:schemeClr val="accent1">
+              <a:shade val="45000"/>
+            </a:schemeClr>
           </a:fillRef>
           <a:effectRef idx="3">
             <a:schemeClr val="accent1"/>
@@ -6142,13 +6194,15 @@
             <a:schemeClr val="accent2"/>
           </a:lnRef>
           <a:fillRef idx="1">
-            <a:schemeClr val="accent2"/>
+            <a:schemeClr val="accent2">
+              <a:shade val="32500"/>
+            </a:schemeClr>
           </a:fillRef>
           <a:effectRef idx="3">
             <a:schemeClr val="accent2"/>
           </a:effectRef>
           <a:fontRef idx="minor">
-            <a:schemeClr val="tx1"/>
+            <a:schemeClr val="lt1"/>
           </a:fontRef>
         </p:style>
         <p:txBody>
@@ -6163,7 +6217,7 @@
             <a:r>
               <a:rPr lang="zh-TW" sz="2000" b="1">
                 <a:solidFill>
-                  <a:schemeClr val="tx1"/>
+                  <a:schemeClr val="lt1"/>
                 </a:solidFill>
                 <a:latin typeface="+mn-lt"/>
                 <a:ea typeface="+mn-ea"/>
@@ -6197,7 +6251,9 @@
             <a:schemeClr val="accent3"/>
           </a:lnRef>
           <a:fillRef idx="1">
-            <a:schemeClr val="accent3"/>
+            <a:schemeClr val="accent3">
+              <a:shade val="45000"/>
+            </a:schemeClr>
           </a:fillRef>
           <a:effectRef idx="3">
             <a:schemeClr val="accent3"/>
@@ -6252,7 +6308,9 @@
             <a:schemeClr val="accent4"/>
           </a:lnRef>
           <a:fillRef idx="1">
-            <a:schemeClr val="accent4"/>
+            <a:schemeClr val="accent4">
+              <a:shade val="45000"/>
+            </a:schemeClr>
           </a:fillRef>
           <a:effectRef idx="3">
             <a:schemeClr val="accent4"/>
@@ -6307,7 +6365,9 @@
             <a:schemeClr val="accent5"/>
           </a:lnRef>
           <a:fillRef idx="1">
-            <a:schemeClr val="accent5"/>
+            <a:schemeClr val="accent5">
+              <a:shade val="45000"/>
+            </a:schemeClr>
           </a:fillRef>
           <a:effectRef idx="3">
             <a:schemeClr val="accent5"/>
@@ -6362,7 +6422,9 @@
             <a:schemeClr val="accent6"/>
           </a:lnRef>
           <a:fillRef idx="1">
-            <a:schemeClr val="accent6"/>
+            <a:schemeClr val="accent6">
+              <a:shade val="45000"/>
+            </a:schemeClr>
           </a:fillRef>
           <a:effectRef idx="3">
             <a:schemeClr val="accent6"/>
@@ -6557,7 +6619,7 @@
         <a:font script="Geor" typeface="Sylfaen"/>
       </a:minorFont>
     </a:fontScheme>
-    <a:fmtScheme name="PPT Template Style Kit">
+    <a:fmtScheme name="PPT Style Studio component effects">
       <a:fillStyleLst>
         <a:solidFill>
           <a:schemeClr val="phClr"/>
@@ -6566,12 +6628,13 @@
           <a:gsLst>
             <a:gs pos="0">
               <a:schemeClr val="phClr">
-                <a:lumMod val="60000"/>
-                <a:lumOff val="40000"/>
+                <a:tint val="95000"/>
               </a:schemeClr>
             </a:gs>
             <a:gs pos="100000">
-              <a:schemeClr val="phClr"/>
+              <a:schemeClr val="phClr">
+                <a:shade val="95000"/>
+              </a:schemeClr>
             </a:gs>
           </a:gsLst>
           <a:lin ang="5400000" scaled="0"/>
@@ -6580,14 +6643,12 @@
           <a:gsLst>
             <a:gs pos="0">
               <a:schemeClr val="phClr">
-                <a:lumMod val="20000"/>
-                <a:lumOff val="80000"/>
+                <a:tint val="12000"/>
               </a:schemeClr>
             </a:gs>
             <a:gs pos="100000">
               <a:schemeClr val="phClr">
-                <a:lumMod val="40000"/>
-                <a:lumOff val="60000"/>
+                <a:tint val="20000"/>
               </a:schemeClr>
             </a:gs>
           </a:gsLst>
@@ -6609,9 +6670,11 @@
           <a:prstDash val="solid"/>
           <a:miter lim="800000"/>
         </a:ln>
-        <a:ln w="19050" cap="flat" cmpd="sng" algn="ctr">
+        <a:ln w="9525" cap="flat" cmpd="sng" algn="ctr">
           <a:solidFill>
-            <a:schemeClr val="phClr"/>
+            <a:schemeClr val="phClr">
+              <a:tint val="30000"/>
+            </a:schemeClr>
           </a:solidFill>
           <a:prstDash val="solid"/>
           <a:miter lim="800000"/>
@@ -6619,16 +6682,28 @@
       </a:lnStyleLst>
       <a:effectStyleLst>
         <a:effectStyle>
-          <a:effectLst/>
-        </a:effectStyle>
-        <a:effectStyle>
-          <a:effectLst/>
+          <a:effectLst>
+            <a:outerShdw blurRad="53340" dist="19050" dir="5400000" algn="ctr" rotWithShape="0">
+              <a:srgbClr val="000000">
+                <a:alpha val="20000"/>
+              </a:srgbClr>
+            </a:outerShdw>
+          </a:effectLst>
         </a:effectStyle>
         <a:effectStyle>
           <a:effectLst>
-            <a:outerShdw blurRad="76200" dist="19050" dir="5400000" algn="t" rotWithShape="0">
+            <a:outerShdw blurRad="88900" dist="25400" dir="5400000" algn="ctr" rotWithShape="0">
               <a:srgbClr val="000000">
                 <a:alpha val="18000"/>
+              </a:srgbClr>
+            </a:outerShdw>
+          </a:effectLst>
+        </a:effectStyle>
+        <a:effectStyle>
+          <a:effectLst>
+            <a:outerShdw blurRad="88900" dist="25400" dir="5400000" algn="ctr" rotWithShape="0">
+              <a:srgbClr val="000000">
+                <a:alpha val="24000"/>
               </a:srgbClr>
             </a:outerShdw>
           </a:effectLst>

</xml_diff>